<commit_message>
update bottom_DO_plots.py DO occurrence plots for white zero occurrence days
</commit_message>
<xml_diff>
--- a/intermodel_comparison/dens_profiles.pptx
+++ b/intermodel_comparison/dens_profiles.pptx
@@ -5,9 +5,20 @@
     <p:sldMasterId id="2147483648" r:id="rId1"/>
   </p:sldMasterIdLst>
   <p:sldIdLst>
-    <p:sldId id="256" r:id="rId2"/>
-    <p:sldId id="257" r:id="rId3"/>
-    <p:sldId id="258" r:id="rId4"/>
+    <p:sldId id="260" r:id="rId2"/>
+    <p:sldId id="269" r:id="rId3"/>
+    <p:sldId id="270" r:id="rId4"/>
+    <p:sldId id="271" r:id="rId5"/>
+    <p:sldId id="272" r:id="rId6"/>
+    <p:sldId id="259" r:id="rId7"/>
+    <p:sldId id="261" r:id="rId8"/>
+    <p:sldId id="266" r:id="rId9"/>
+    <p:sldId id="262" r:id="rId10"/>
+    <p:sldId id="263" r:id="rId11"/>
+    <p:sldId id="267" r:id="rId12"/>
+    <p:sldId id="265" r:id="rId13"/>
+    <p:sldId id="264" r:id="rId14"/>
+    <p:sldId id="268" r:id="rId15"/>
   </p:sldIdLst>
   <p:sldSz cx="12192000" cy="6858000"/>
   <p:notesSz cx="6858000" cy="9144000"/>
@@ -106,6 +117,11 @@
       </a:defRPr>
     </a:lvl9pPr>
   </p:defaultTextStyle>
+  <p:extLst>
+    <p:ext uri="{EFAFB233-063F-42B5-8137-9DF3F51BA10A}">
+      <p15:sldGuideLst xmlns:p15="http://schemas.microsoft.com/office/powerpoint/2012/main"/>
+    </p:ext>
+  </p:extLst>
 </p:presentation>
 </file>
 
@@ -256,7 +272,7 @@
           <a:p>
             <a:fld id="{CF541E7A-D5C2-4AC6-B7D5-58B68EFAB35C}" type="datetimeFigureOut">
               <a:rPr lang="en-US" smtClean="0"/>
-              <a:t>8/4/2026</a:t>
+              <a:t>9/9/2026</a:t>
             </a:fld>
             <a:endParaRPr lang="en-US"/>
           </a:p>
@@ -454,7 +470,7 @@
           <a:p>
             <a:fld id="{CF541E7A-D5C2-4AC6-B7D5-58B68EFAB35C}" type="datetimeFigureOut">
               <a:rPr lang="en-US" smtClean="0"/>
-              <a:t>8/4/2026</a:t>
+              <a:t>9/9/2026</a:t>
             </a:fld>
             <a:endParaRPr lang="en-US"/>
           </a:p>
@@ -662,7 +678,7 @@
           <a:p>
             <a:fld id="{CF541E7A-D5C2-4AC6-B7D5-58B68EFAB35C}" type="datetimeFigureOut">
               <a:rPr lang="en-US" smtClean="0"/>
-              <a:t>8/4/2026</a:t>
+              <a:t>9/9/2026</a:t>
             </a:fld>
             <a:endParaRPr lang="en-US"/>
           </a:p>
@@ -860,7 +876,7 @@
           <a:p>
             <a:fld id="{CF541E7A-D5C2-4AC6-B7D5-58B68EFAB35C}" type="datetimeFigureOut">
               <a:rPr lang="en-US" smtClean="0"/>
-              <a:t>8/4/2026</a:t>
+              <a:t>9/9/2026</a:t>
             </a:fld>
             <a:endParaRPr lang="en-US"/>
           </a:p>
@@ -1135,7 +1151,7 @@
           <a:p>
             <a:fld id="{CF541E7A-D5C2-4AC6-B7D5-58B68EFAB35C}" type="datetimeFigureOut">
               <a:rPr lang="en-US" smtClean="0"/>
-              <a:t>8/4/2026</a:t>
+              <a:t>9/9/2026</a:t>
             </a:fld>
             <a:endParaRPr lang="en-US"/>
           </a:p>
@@ -1400,7 +1416,7 @@
           <a:p>
             <a:fld id="{CF541E7A-D5C2-4AC6-B7D5-58B68EFAB35C}" type="datetimeFigureOut">
               <a:rPr lang="en-US" smtClean="0"/>
-              <a:t>8/4/2026</a:t>
+              <a:t>9/9/2026</a:t>
             </a:fld>
             <a:endParaRPr lang="en-US"/>
           </a:p>
@@ -1812,7 +1828,7 @@
           <a:p>
             <a:fld id="{CF541E7A-D5C2-4AC6-B7D5-58B68EFAB35C}" type="datetimeFigureOut">
               <a:rPr lang="en-US" smtClean="0"/>
-              <a:t>8/4/2026</a:t>
+              <a:t>9/9/2026</a:t>
             </a:fld>
             <a:endParaRPr lang="en-US"/>
           </a:p>
@@ -1953,7 +1969,7 @@
           <a:p>
             <a:fld id="{CF541E7A-D5C2-4AC6-B7D5-58B68EFAB35C}" type="datetimeFigureOut">
               <a:rPr lang="en-US" smtClean="0"/>
-              <a:t>8/4/2026</a:t>
+              <a:t>9/9/2026</a:t>
             </a:fld>
             <a:endParaRPr lang="en-US"/>
           </a:p>
@@ -2066,7 +2082,7 @@
           <a:p>
             <a:fld id="{CF541E7A-D5C2-4AC6-B7D5-58B68EFAB35C}" type="datetimeFigureOut">
               <a:rPr lang="en-US" smtClean="0"/>
-              <a:t>8/4/2026</a:t>
+              <a:t>9/9/2026</a:t>
             </a:fld>
             <a:endParaRPr lang="en-US"/>
           </a:p>
@@ -2377,7 +2393,7 @@
           <a:p>
             <a:fld id="{CF541E7A-D5C2-4AC6-B7D5-58B68EFAB35C}" type="datetimeFigureOut">
               <a:rPr lang="en-US" smtClean="0"/>
-              <a:t>8/4/2026</a:t>
+              <a:t>9/9/2026</a:t>
             </a:fld>
             <a:endParaRPr lang="en-US"/>
           </a:p>
@@ -2665,7 +2681,7 @@
           <a:p>
             <a:fld id="{CF541E7A-D5C2-4AC6-B7D5-58B68EFAB35C}" type="datetimeFigureOut">
               <a:rPr lang="en-US" smtClean="0"/>
-              <a:t>8/4/2026</a:t>
+              <a:t>9/9/2026</a:t>
             </a:fld>
             <a:endParaRPr lang="en-US"/>
           </a:p>
@@ -2906,7 +2922,7 @@
           <a:p>
             <a:fld id="{CF541E7A-D5C2-4AC6-B7D5-58B68EFAB35C}" type="datetimeFigureOut">
               <a:rPr lang="en-US" smtClean="0"/>
-              <a:t>8/4/2026</a:t>
+              <a:t>9/9/2026</a:t>
             </a:fld>
             <a:endParaRPr lang="en-US"/>
           </a:p>
@@ -3328,7 +3344,68 @@
           <p:cNvPr id="5" name="Picture 4">
             <a:extLst>
               <a:ext uri="{FF2B5EF4-FFF2-40B4-BE49-F238E27FC236}">
-                <a16:creationId xmlns:a16="http://schemas.microsoft.com/office/drawing/2014/main" id="{466140E2-CDD2-3AD0-C05C-5C68F78A01D2}"/>
+                <a16:creationId xmlns:a16="http://schemas.microsoft.com/office/drawing/2014/main" id="{CAF2018D-DD6C-6A01-53B9-BB573717A58A}"/>
+              </a:ext>
+            </a:extLst>
+          </p:cNvPr>
+          <p:cNvPicPr>
+            <a:picLocks noChangeAspect="1"/>
+          </p:cNvPicPr>
+          <p:nvPr/>
+        </p:nvPicPr>
+        <p:blipFill>
+          <a:blip r:embed="rId2"/>
+          <a:srcRect t="5170" r="33814"/>
+          <a:stretch>
+            <a:fillRect/>
+          </a:stretch>
+        </p:blipFill>
+        <p:spPr>
+          <a:xfrm>
+            <a:off x="397565" y="808767"/>
+            <a:ext cx="3387148" cy="5461865"/>
+          </a:xfrm>
+          <a:prstGeom prst="rect">
+            <a:avLst/>
+          </a:prstGeom>
+        </p:spPr>
+      </p:pic>
+    </p:spTree>
+    <p:extLst>
+      <p:ext uri="{BB962C8B-B14F-4D97-AF65-F5344CB8AC3E}">
+        <p14:creationId xmlns:p14="http://schemas.microsoft.com/office/powerpoint/2010/main" val="560236247"/>
+      </p:ext>
+    </p:extLst>
+  </p:cSld>
+  <p:clrMapOvr>
+    <a:masterClrMapping/>
+  </p:clrMapOvr>
+</p:sld>
+</file>
+
+<file path=ppt/slides/slide10.xml><?xml version="1.0" encoding="utf-8"?>
+<p:sld xmlns:a="http://schemas.openxmlformats.org/drawingml/2006/main" xmlns:r="http://schemas.openxmlformats.org/officeDocument/2006/relationships" xmlns:p="http://schemas.openxmlformats.org/presentationml/2006/main">
+  <p:cSld>
+    <p:spTree>
+      <p:nvGrpSpPr>
+        <p:cNvPr id="1" name=""/>
+        <p:cNvGrpSpPr/>
+        <p:nvPr/>
+      </p:nvGrpSpPr>
+      <p:grpSpPr>
+        <a:xfrm>
+          <a:off x="0" y="0"/>
+          <a:ext cx="0" cy="0"/>
+          <a:chOff x="0" y="0"/>
+          <a:chExt cx="0" cy="0"/>
+        </a:xfrm>
+      </p:grpSpPr>
+      <p:pic>
+        <p:nvPicPr>
+          <p:cNvPr id="5" name="Picture 4">
+            <a:extLst>
+              <a:ext uri="{FF2B5EF4-FFF2-40B4-BE49-F238E27FC236}">
+                <a16:creationId xmlns:a16="http://schemas.microsoft.com/office/drawing/2014/main" id="{8541A537-E0D1-B002-732F-C662EBEC3EEA}"/>
               </a:ext>
             </a:extLst>
           </p:cNvPr>
@@ -3345,8 +3422,8 @@
         </p:blipFill>
         <p:spPr>
           <a:xfrm>
-            <a:off x="649011" y="795337"/>
-            <a:ext cx="3981450" cy="5267325"/>
+            <a:off x="0" y="2823359"/>
+            <a:ext cx="8530814" cy="2121969"/>
           </a:xfrm>
           <a:prstGeom prst="rect">
             <a:avLst/>
@@ -3358,7 +3435,7 @@
           <p:cNvPr id="7" name="Picture 6">
             <a:extLst>
               <a:ext uri="{FF2B5EF4-FFF2-40B4-BE49-F238E27FC236}">
-                <a16:creationId xmlns:a16="http://schemas.microsoft.com/office/drawing/2014/main" id="{E3BB6F63-6612-8831-A0CD-D3287CC90BDB}"/>
+                <a16:creationId xmlns:a16="http://schemas.microsoft.com/office/drawing/2014/main" id="{F996FAF9-E4B0-6751-AB48-481E2D8D2835}"/>
               </a:ext>
             </a:extLst>
           </p:cNvPr>
@@ -3375,8 +3452,8 @@
         </p:blipFill>
         <p:spPr>
           <a:xfrm>
-            <a:off x="5161152" y="757502"/>
-            <a:ext cx="3981450" cy="5242243"/>
+            <a:off x="0" y="800415"/>
+            <a:ext cx="12192000" cy="1814723"/>
           </a:xfrm>
           <a:prstGeom prst="rect">
             <a:avLst/>
@@ -3386,7 +3463,367 @@
     </p:spTree>
     <p:extLst>
       <p:ext uri="{BB962C8B-B14F-4D97-AF65-F5344CB8AC3E}">
-        <p14:creationId xmlns:p14="http://schemas.microsoft.com/office/powerpoint/2010/main" val="2591244112"/>
+        <p14:creationId xmlns:p14="http://schemas.microsoft.com/office/powerpoint/2010/main" val="3586284321"/>
+      </p:ext>
+    </p:extLst>
+  </p:cSld>
+  <p:clrMapOvr>
+    <a:masterClrMapping/>
+  </p:clrMapOvr>
+</p:sld>
+</file>
+
+<file path=ppt/slides/slide11.xml><?xml version="1.0" encoding="utf-8"?>
+<p:sld xmlns:a="http://schemas.openxmlformats.org/drawingml/2006/main" xmlns:r="http://schemas.openxmlformats.org/officeDocument/2006/relationships" xmlns:p="http://schemas.openxmlformats.org/presentationml/2006/main">
+  <p:cSld>
+    <p:spTree>
+      <p:nvGrpSpPr>
+        <p:cNvPr id="1" name=""/>
+        <p:cNvGrpSpPr/>
+        <p:nvPr/>
+      </p:nvGrpSpPr>
+      <p:grpSpPr>
+        <a:xfrm>
+          <a:off x="0" y="0"/>
+          <a:ext cx="0" cy="0"/>
+          <a:chOff x="0" y="0"/>
+          <a:chExt cx="0" cy="0"/>
+        </a:xfrm>
+      </p:grpSpPr>
+      <p:pic>
+        <p:nvPicPr>
+          <p:cNvPr id="5" name="Picture 4">
+            <a:extLst>
+              <a:ext uri="{FF2B5EF4-FFF2-40B4-BE49-F238E27FC236}">
+                <a16:creationId xmlns:a16="http://schemas.microsoft.com/office/drawing/2014/main" id="{7D084ACC-39C9-129E-58B7-73165AA6049A}"/>
+              </a:ext>
+            </a:extLst>
+          </p:cNvPr>
+          <p:cNvPicPr>
+            <a:picLocks noChangeAspect="1"/>
+          </p:cNvPicPr>
+          <p:nvPr/>
+        </p:nvPicPr>
+        <p:blipFill>
+          <a:blip r:embed="rId2"/>
+          <a:stretch>
+            <a:fillRect/>
+          </a:stretch>
+        </p:blipFill>
+        <p:spPr>
+          <a:xfrm>
+            <a:off x="0" y="742177"/>
+            <a:ext cx="12192000" cy="2017259"/>
+          </a:xfrm>
+          <a:prstGeom prst="rect">
+            <a:avLst/>
+          </a:prstGeom>
+        </p:spPr>
+      </p:pic>
+      <p:pic>
+        <p:nvPicPr>
+          <p:cNvPr id="7" name="Picture 6">
+            <a:extLst>
+              <a:ext uri="{FF2B5EF4-FFF2-40B4-BE49-F238E27FC236}">
+                <a16:creationId xmlns:a16="http://schemas.microsoft.com/office/drawing/2014/main" id="{4F82C956-3C16-9FAF-50F0-9B2D6A7F08BB}"/>
+              </a:ext>
+            </a:extLst>
+          </p:cNvPr>
+          <p:cNvPicPr>
+            <a:picLocks noChangeAspect="1"/>
+          </p:cNvPicPr>
+          <p:nvPr/>
+        </p:nvPicPr>
+        <p:blipFill>
+          <a:blip r:embed="rId3"/>
+          <a:stretch>
+            <a:fillRect/>
+          </a:stretch>
+        </p:blipFill>
+        <p:spPr>
+          <a:xfrm>
+            <a:off x="0" y="2802772"/>
+            <a:ext cx="8670664" cy="2591585"/>
+          </a:xfrm>
+          <a:prstGeom prst="rect">
+            <a:avLst/>
+          </a:prstGeom>
+        </p:spPr>
+      </p:pic>
+    </p:spTree>
+    <p:extLst>
+      <p:ext uri="{BB962C8B-B14F-4D97-AF65-F5344CB8AC3E}">
+        <p14:creationId xmlns:p14="http://schemas.microsoft.com/office/powerpoint/2010/main" val="526955434"/>
+      </p:ext>
+    </p:extLst>
+  </p:cSld>
+  <p:clrMapOvr>
+    <a:masterClrMapping/>
+  </p:clrMapOvr>
+</p:sld>
+</file>
+
+<file path=ppt/slides/slide12.xml><?xml version="1.0" encoding="utf-8"?>
+<p:sld xmlns:a="http://schemas.openxmlformats.org/drawingml/2006/main" xmlns:r="http://schemas.openxmlformats.org/officeDocument/2006/relationships" xmlns:p="http://schemas.openxmlformats.org/presentationml/2006/main">
+  <p:cSld>
+    <p:spTree>
+      <p:nvGrpSpPr>
+        <p:cNvPr id="1" name=""/>
+        <p:cNvGrpSpPr/>
+        <p:nvPr/>
+      </p:nvGrpSpPr>
+      <p:grpSpPr>
+        <a:xfrm>
+          <a:off x="0" y="0"/>
+          <a:ext cx="0" cy="0"/>
+          <a:chOff x="0" y="0"/>
+          <a:chExt cx="0" cy="0"/>
+        </a:xfrm>
+      </p:grpSpPr>
+      <p:pic>
+        <p:nvPicPr>
+          <p:cNvPr id="5" name="Picture 4">
+            <a:extLst>
+              <a:ext uri="{FF2B5EF4-FFF2-40B4-BE49-F238E27FC236}">
+                <a16:creationId xmlns:a16="http://schemas.microsoft.com/office/drawing/2014/main" id="{F84A2C84-B2A5-B856-714D-4187B70481F4}"/>
+              </a:ext>
+            </a:extLst>
+          </p:cNvPr>
+          <p:cNvPicPr>
+            <a:picLocks noChangeAspect="1"/>
+          </p:cNvPicPr>
+          <p:nvPr/>
+        </p:nvPicPr>
+        <p:blipFill>
+          <a:blip r:embed="rId2"/>
+          <a:stretch>
+            <a:fillRect/>
+          </a:stretch>
+        </p:blipFill>
+        <p:spPr>
+          <a:xfrm>
+            <a:off x="398033" y="3394038"/>
+            <a:ext cx="8702936" cy="2585591"/>
+          </a:xfrm>
+          <a:prstGeom prst="rect">
+            <a:avLst/>
+          </a:prstGeom>
+        </p:spPr>
+      </p:pic>
+      <p:pic>
+        <p:nvPicPr>
+          <p:cNvPr id="7" name="Picture 6">
+            <a:extLst>
+              <a:ext uri="{FF2B5EF4-FFF2-40B4-BE49-F238E27FC236}">
+                <a16:creationId xmlns:a16="http://schemas.microsoft.com/office/drawing/2014/main" id="{EFEB4D8C-CB5A-A460-6AB2-585F251B7D47}"/>
+              </a:ext>
+            </a:extLst>
+          </p:cNvPr>
+          <p:cNvPicPr>
+            <a:picLocks noChangeAspect="1"/>
+          </p:cNvPicPr>
+          <p:nvPr/>
+        </p:nvPicPr>
+        <p:blipFill>
+          <a:blip r:embed="rId3"/>
+          <a:stretch>
+            <a:fillRect/>
+          </a:stretch>
+        </p:blipFill>
+        <p:spPr>
+          <a:xfrm>
+            <a:off x="0" y="1229637"/>
+            <a:ext cx="12192000" cy="2010527"/>
+          </a:xfrm>
+          <a:prstGeom prst="rect">
+            <a:avLst/>
+          </a:prstGeom>
+        </p:spPr>
+      </p:pic>
+    </p:spTree>
+    <p:extLst>
+      <p:ext uri="{BB962C8B-B14F-4D97-AF65-F5344CB8AC3E}">
+        <p14:creationId xmlns:p14="http://schemas.microsoft.com/office/powerpoint/2010/main" val="3237923289"/>
+      </p:ext>
+    </p:extLst>
+  </p:cSld>
+  <p:clrMapOvr>
+    <a:masterClrMapping/>
+  </p:clrMapOvr>
+</p:sld>
+</file>
+
+<file path=ppt/slides/slide13.xml><?xml version="1.0" encoding="utf-8"?>
+<p:sld xmlns:a="http://schemas.openxmlformats.org/drawingml/2006/main" xmlns:r="http://schemas.openxmlformats.org/officeDocument/2006/relationships" xmlns:p="http://schemas.openxmlformats.org/presentationml/2006/main">
+  <p:cSld>
+    <p:spTree>
+      <p:nvGrpSpPr>
+        <p:cNvPr id="1" name=""/>
+        <p:cNvGrpSpPr/>
+        <p:nvPr/>
+      </p:nvGrpSpPr>
+      <p:grpSpPr>
+        <a:xfrm>
+          <a:off x="0" y="0"/>
+          <a:ext cx="0" cy="0"/>
+          <a:chOff x="0" y="0"/>
+          <a:chExt cx="0" cy="0"/>
+        </a:xfrm>
+      </p:grpSpPr>
+      <p:pic>
+        <p:nvPicPr>
+          <p:cNvPr id="6" name="Picture 5">
+            <a:extLst>
+              <a:ext uri="{FF2B5EF4-FFF2-40B4-BE49-F238E27FC236}">
+                <a16:creationId xmlns:a16="http://schemas.microsoft.com/office/drawing/2014/main" id="{CC316B3B-6971-9406-E039-A019826B3AA2}"/>
+              </a:ext>
+            </a:extLst>
+          </p:cNvPr>
+          <p:cNvPicPr>
+            <a:picLocks noChangeAspect="1"/>
+          </p:cNvPicPr>
+          <p:nvPr/>
+        </p:nvPicPr>
+        <p:blipFill>
+          <a:blip r:embed="rId2"/>
+          <a:stretch>
+            <a:fillRect/>
+          </a:stretch>
+        </p:blipFill>
+        <p:spPr>
+          <a:xfrm>
+            <a:off x="129090" y="953747"/>
+            <a:ext cx="12058437" cy="1789453"/>
+          </a:xfrm>
+          <a:prstGeom prst="rect">
+            <a:avLst/>
+          </a:prstGeom>
+        </p:spPr>
+      </p:pic>
+      <p:pic>
+        <p:nvPicPr>
+          <p:cNvPr id="8" name="Picture 7">
+            <a:extLst>
+              <a:ext uri="{FF2B5EF4-FFF2-40B4-BE49-F238E27FC236}">
+                <a16:creationId xmlns:a16="http://schemas.microsoft.com/office/drawing/2014/main" id="{45ABF78A-4534-AED3-DECD-55961DF9C9B0}"/>
+              </a:ext>
+            </a:extLst>
+          </p:cNvPr>
+          <p:cNvPicPr>
+            <a:picLocks noChangeAspect="1"/>
+          </p:cNvPicPr>
+          <p:nvPr/>
+        </p:nvPicPr>
+        <p:blipFill>
+          <a:blip r:embed="rId3"/>
+          <a:stretch>
+            <a:fillRect/>
+          </a:stretch>
+        </p:blipFill>
+        <p:spPr>
+          <a:xfrm>
+            <a:off x="0" y="2743200"/>
+            <a:ext cx="8380209" cy="2074067"/>
+          </a:xfrm>
+          <a:prstGeom prst="rect">
+            <a:avLst/>
+          </a:prstGeom>
+        </p:spPr>
+      </p:pic>
+    </p:spTree>
+    <p:extLst>
+      <p:ext uri="{BB962C8B-B14F-4D97-AF65-F5344CB8AC3E}">
+        <p14:creationId xmlns:p14="http://schemas.microsoft.com/office/powerpoint/2010/main" val="1589379539"/>
+      </p:ext>
+    </p:extLst>
+  </p:cSld>
+  <p:clrMapOvr>
+    <a:masterClrMapping/>
+  </p:clrMapOvr>
+</p:sld>
+</file>
+
+<file path=ppt/slides/slide14.xml><?xml version="1.0" encoding="utf-8"?>
+<p:sld xmlns:a="http://schemas.openxmlformats.org/drawingml/2006/main" xmlns:r="http://schemas.openxmlformats.org/officeDocument/2006/relationships" xmlns:p="http://schemas.openxmlformats.org/presentationml/2006/main">
+  <p:cSld>
+    <p:spTree>
+      <p:nvGrpSpPr>
+        <p:cNvPr id="1" name=""/>
+        <p:cNvGrpSpPr/>
+        <p:nvPr/>
+      </p:nvGrpSpPr>
+      <p:grpSpPr>
+        <a:xfrm>
+          <a:off x="0" y="0"/>
+          <a:ext cx="0" cy="0"/>
+          <a:chOff x="0" y="0"/>
+          <a:chExt cx="0" cy="0"/>
+        </a:xfrm>
+      </p:grpSpPr>
+      <p:pic>
+        <p:nvPicPr>
+          <p:cNvPr id="5" name="Picture 4">
+            <a:extLst>
+              <a:ext uri="{FF2B5EF4-FFF2-40B4-BE49-F238E27FC236}">
+                <a16:creationId xmlns:a16="http://schemas.microsoft.com/office/drawing/2014/main" id="{C39B8D6D-D7A7-99C6-1084-42931495E7F0}"/>
+              </a:ext>
+            </a:extLst>
+          </p:cNvPr>
+          <p:cNvPicPr>
+            <a:picLocks noChangeAspect="1"/>
+          </p:cNvPicPr>
+          <p:nvPr/>
+        </p:nvPicPr>
+        <p:blipFill>
+          <a:blip r:embed="rId2"/>
+          <a:stretch>
+            <a:fillRect/>
+          </a:stretch>
+        </p:blipFill>
+        <p:spPr>
+          <a:xfrm>
+            <a:off x="139850" y="562663"/>
+            <a:ext cx="12192000" cy="2010527"/>
+          </a:xfrm>
+          <a:prstGeom prst="rect">
+            <a:avLst/>
+          </a:prstGeom>
+        </p:spPr>
+      </p:pic>
+      <p:pic>
+        <p:nvPicPr>
+          <p:cNvPr id="7" name="Picture 6">
+            <a:extLst>
+              <a:ext uri="{FF2B5EF4-FFF2-40B4-BE49-F238E27FC236}">
+                <a16:creationId xmlns:a16="http://schemas.microsoft.com/office/drawing/2014/main" id="{8F7DCCC5-4EB7-8AED-EB84-A27928802D04}"/>
+              </a:ext>
+            </a:extLst>
+          </p:cNvPr>
+          <p:cNvPicPr>
+            <a:picLocks noChangeAspect="1"/>
+          </p:cNvPicPr>
+          <p:nvPr/>
+        </p:nvPicPr>
+        <p:blipFill>
+          <a:blip r:embed="rId3"/>
+          <a:stretch>
+            <a:fillRect/>
+          </a:stretch>
+        </p:blipFill>
+        <p:spPr>
+          <a:xfrm>
+            <a:off x="139850" y="2737985"/>
+            <a:ext cx="8928847" cy="2652708"/>
+          </a:xfrm>
+          <a:prstGeom prst="rect">
+            <a:avLst/>
+          </a:prstGeom>
+        </p:spPr>
+      </p:pic>
+    </p:spTree>
+    <p:extLst>
+      <p:ext uri="{BB962C8B-B14F-4D97-AF65-F5344CB8AC3E}">
+        <p14:creationId xmlns:p14="http://schemas.microsoft.com/office/powerpoint/2010/main" val="1951118110"/>
       </p:ext>
     </p:extLst>
   </p:cSld>
@@ -3415,10 +3852,10 @@
       </p:grpSpPr>
       <p:pic>
         <p:nvPicPr>
-          <p:cNvPr id="5" name="Picture 4">
-            <a:extLst>
-              <a:ext uri="{FF2B5EF4-FFF2-40B4-BE49-F238E27FC236}">
-                <a16:creationId xmlns:a16="http://schemas.microsoft.com/office/drawing/2014/main" id="{F2662768-57EA-6C11-2C3C-5FD3AEBEED75}"/>
+          <p:cNvPr id="7" name="Picture 6">
+            <a:extLst>
+              <a:ext uri="{FF2B5EF4-FFF2-40B4-BE49-F238E27FC236}">
+                <a16:creationId xmlns:a16="http://schemas.microsoft.com/office/drawing/2014/main" id="{97C2ABFA-690E-0495-757A-0015813F1A1A}"/>
               </a:ext>
             </a:extLst>
           </p:cNvPr>
@@ -3435,8 +3872,8 @@
         </p:blipFill>
         <p:spPr>
           <a:xfrm>
-            <a:off x="5161152" y="946338"/>
-            <a:ext cx="4000500" cy="5267325"/>
+            <a:off x="129091" y="2481215"/>
+            <a:ext cx="7035501" cy="2102849"/>
           </a:xfrm>
           <a:prstGeom prst="rect">
             <a:avLst/>
@@ -3445,10 +3882,10 @@
       </p:pic>
       <p:pic>
         <p:nvPicPr>
-          <p:cNvPr id="7" name="Picture 6">
-            <a:extLst>
-              <a:ext uri="{FF2B5EF4-FFF2-40B4-BE49-F238E27FC236}">
-                <a16:creationId xmlns:a16="http://schemas.microsoft.com/office/drawing/2014/main" id="{2A22B60F-8D63-B08F-AA30-A2C097EECA60}"/>
+          <p:cNvPr id="9" name="Picture 8">
+            <a:extLst>
+              <a:ext uri="{FF2B5EF4-FFF2-40B4-BE49-F238E27FC236}">
+                <a16:creationId xmlns:a16="http://schemas.microsoft.com/office/drawing/2014/main" id="{18A905D5-0C89-6369-B3D6-FCCA4DFDF147}"/>
               </a:ext>
             </a:extLst>
           </p:cNvPr>
@@ -3465,18 +3902,123 @@
         </p:blipFill>
         <p:spPr>
           <a:xfrm>
-            <a:off x="992960" y="946338"/>
-            <a:ext cx="3981450" cy="5267325"/>
+            <a:off x="151670" y="4584064"/>
+            <a:ext cx="7078056" cy="2102849"/>
           </a:xfrm>
           <a:prstGeom prst="rect">
             <a:avLst/>
           </a:prstGeom>
         </p:spPr>
       </p:pic>
+      <p:pic>
+        <p:nvPicPr>
+          <p:cNvPr id="11" name="Picture 10">
+            <a:extLst>
+              <a:ext uri="{FF2B5EF4-FFF2-40B4-BE49-F238E27FC236}">
+                <a16:creationId xmlns:a16="http://schemas.microsoft.com/office/drawing/2014/main" id="{2940F589-A10F-7F17-860D-4F882F14C1E4}"/>
+              </a:ext>
+            </a:extLst>
+          </p:cNvPr>
+          <p:cNvPicPr>
+            <a:picLocks noChangeAspect="1"/>
+          </p:cNvPicPr>
+          <p:nvPr/>
+        </p:nvPicPr>
+        <p:blipFill>
+          <a:blip r:embed="rId4"/>
+          <a:stretch>
+            <a:fillRect/>
+          </a:stretch>
+        </p:blipFill>
+        <p:spPr>
+          <a:xfrm>
+            <a:off x="129091" y="349480"/>
+            <a:ext cx="7078057" cy="2109190"/>
+          </a:xfrm>
+          <a:prstGeom prst="rect">
+            <a:avLst/>
+          </a:prstGeom>
+        </p:spPr>
+      </p:pic>
+      <p:pic>
+        <p:nvPicPr>
+          <p:cNvPr id="5" name="Picture 4">
+            <a:extLst>
+              <a:ext uri="{FF2B5EF4-FFF2-40B4-BE49-F238E27FC236}">
+                <a16:creationId xmlns:a16="http://schemas.microsoft.com/office/drawing/2014/main" id="{9DCF42FD-A679-A06F-A766-6763D83DDCFD}"/>
+              </a:ext>
+            </a:extLst>
+          </p:cNvPr>
+          <p:cNvPicPr>
+            <a:picLocks noChangeAspect="1"/>
+          </p:cNvPicPr>
+          <p:nvPr/>
+        </p:nvPicPr>
+        <p:blipFill>
+          <a:blip r:embed="rId5"/>
+          <a:srcRect l="9602" t="5170" r="33814" b="10008"/>
+          <a:stretch>
+            <a:fillRect/>
+          </a:stretch>
+        </p:blipFill>
+        <p:spPr>
+          <a:xfrm>
+            <a:off x="7360355" y="1180495"/>
+            <a:ext cx="2665482" cy="4497009"/>
+          </a:xfrm>
+          <a:prstGeom prst="rect">
+            <a:avLst/>
+          </a:prstGeom>
+        </p:spPr>
+      </p:pic>
+      <p:cxnSp>
+        <p:nvCxnSpPr>
+          <p:cNvPr id="10" name="Straight Arrow Connector 9">
+            <a:extLst>
+              <a:ext uri="{FF2B5EF4-FFF2-40B4-BE49-F238E27FC236}">
+                <a16:creationId xmlns:a16="http://schemas.microsoft.com/office/drawing/2014/main" id="{246BE162-2DD9-AA49-A90F-37C40D84EC8D}"/>
+              </a:ext>
+            </a:extLst>
+          </p:cNvPr>
+          <p:cNvCxnSpPr>
+            <a:cxnSpLocks/>
+          </p:cNvCxnSpPr>
+          <p:nvPr/>
+        </p:nvCxnSpPr>
+        <p:spPr>
+          <a:xfrm flipV="1">
+            <a:off x="8794044" y="1387727"/>
+            <a:ext cx="270934" cy="214489"/>
+          </a:xfrm>
+          <a:prstGeom prst="straightConnector1">
+            <a:avLst/>
+          </a:prstGeom>
+          <a:ln w="57150">
+            <a:solidFill>
+              <a:schemeClr val="tx1"/>
+            </a:solidFill>
+            <a:tailEnd type="triangle"/>
+          </a:ln>
+        </p:spPr>
+        <p:style>
+          <a:lnRef idx="2">
+            <a:schemeClr val="accent1"/>
+          </a:lnRef>
+          <a:fillRef idx="0">
+            <a:schemeClr val="accent1"/>
+          </a:fillRef>
+          <a:effectRef idx="1">
+            <a:schemeClr val="accent1"/>
+          </a:effectRef>
+          <a:fontRef idx="minor">
+            <a:schemeClr val="tx1"/>
+          </a:fontRef>
+        </p:style>
+      </p:cxnSp>
     </p:spTree>
     <p:extLst>
       <p:ext uri="{BB962C8B-B14F-4D97-AF65-F5344CB8AC3E}">
-        <p14:creationId xmlns:p14="http://schemas.microsoft.com/office/powerpoint/2010/main" val="1141701187"/>
+        <p14:creationId xmlns:p14="http://schemas.microsoft.com/office/powerpoint/2010/main" val="568720257"/>
       </p:ext>
     </p:extLst>
   </p:cSld>
@@ -3505,10 +4047,10 @@
       </p:grpSpPr>
       <p:pic>
         <p:nvPicPr>
-          <p:cNvPr id="5" name="Picture 4">
-            <a:extLst>
-              <a:ext uri="{FF2B5EF4-FFF2-40B4-BE49-F238E27FC236}">
-                <a16:creationId xmlns:a16="http://schemas.microsoft.com/office/drawing/2014/main" id="{AC0603D8-4D98-97EA-BDB7-E8F4A57BB7AE}"/>
+          <p:cNvPr id="7" name="Picture 6">
+            <a:extLst>
+              <a:ext uri="{FF2B5EF4-FFF2-40B4-BE49-F238E27FC236}">
+                <a16:creationId xmlns:a16="http://schemas.microsoft.com/office/drawing/2014/main" id="{A60E58B8-95ED-8E7E-3F86-C2199D455F6C}"/>
               </a:ext>
             </a:extLst>
           </p:cNvPr>
@@ -3525,8 +4067,8 @@
         </p:blipFill>
         <p:spPr>
           <a:xfrm>
-            <a:off x="732901" y="1354930"/>
-            <a:ext cx="2838840" cy="3755690"/>
+            <a:off x="14965" y="2394261"/>
+            <a:ext cx="8064075" cy="2005872"/>
           </a:xfrm>
           <a:prstGeom prst="rect">
             <a:avLst/>
@@ -3535,10 +4077,10 @@
       </p:pic>
       <p:pic>
         <p:nvPicPr>
-          <p:cNvPr id="7" name="Picture 6">
-            <a:extLst>
-              <a:ext uri="{FF2B5EF4-FFF2-40B4-BE49-F238E27FC236}">
-                <a16:creationId xmlns:a16="http://schemas.microsoft.com/office/drawing/2014/main" id="{F8470020-BC09-7C12-D3E1-4EBD1E982E4A}"/>
+          <p:cNvPr id="9" name="Picture 8">
+            <a:extLst>
+              <a:ext uri="{FF2B5EF4-FFF2-40B4-BE49-F238E27FC236}">
+                <a16:creationId xmlns:a16="http://schemas.microsoft.com/office/drawing/2014/main" id="{A392AFC7-4514-F4AA-24E3-FE9B6779D8AA}"/>
               </a:ext>
             </a:extLst>
           </p:cNvPr>
@@ -3555,8 +4097,8 @@
         </p:blipFill>
         <p:spPr>
           <a:xfrm>
-            <a:off x="4017772" y="1354930"/>
-            <a:ext cx="2784508" cy="3666269"/>
+            <a:off x="-1955" y="388389"/>
+            <a:ext cx="8080995" cy="2005872"/>
           </a:xfrm>
           <a:prstGeom prst="rect">
             <a:avLst/>
@@ -3565,10 +4107,10 @@
       </p:pic>
       <p:pic>
         <p:nvPicPr>
-          <p:cNvPr id="9" name="Picture 8">
-            <a:extLst>
-              <a:ext uri="{FF2B5EF4-FFF2-40B4-BE49-F238E27FC236}">
-                <a16:creationId xmlns:a16="http://schemas.microsoft.com/office/drawing/2014/main" id="{1DBA48F8-3AAA-D394-9AB3-670F6FC5DAE7}"/>
+          <p:cNvPr id="11" name="Picture 10">
+            <a:extLst>
+              <a:ext uri="{FF2B5EF4-FFF2-40B4-BE49-F238E27FC236}">
+                <a16:creationId xmlns:a16="http://schemas.microsoft.com/office/drawing/2014/main" id="{A7DAED4D-2508-B1EB-BAA8-9E4CBF6A7590}"/>
               </a:ext>
             </a:extLst>
           </p:cNvPr>
@@ -3585,8 +4127,406 @@
         </p:blipFill>
         <p:spPr>
           <a:xfrm>
-            <a:off x="7072863" y="1354931"/>
-            <a:ext cx="2784508" cy="3755690"/>
+            <a:off x="14965" y="4411421"/>
+            <a:ext cx="8104667" cy="2005872"/>
+          </a:xfrm>
+          <a:prstGeom prst="rect">
+            <a:avLst/>
+          </a:prstGeom>
+        </p:spPr>
+      </p:pic>
+      <p:pic>
+        <p:nvPicPr>
+          <p:cNvPr id="2" name="Picture 1">
+            <a:extLst>
+              <a:ext uri="{FF2B5EF4-FFF2-40B4-BE49-F238E27FC236}">
+                <a16:creationId xmlns:a16="http://schemas.microsoft.com/office/drawing/2014/main" id="{367F7F31-6D58-F23A-3021-308C7ED8FECF}"/>
+              </a:ext>
+            </a:extLst>
+          </p:cNvPr>
+          <p:cNvPicPr>
+            <a:picLocks noChangeAspect="1"/>
+          </p:cNvPicPr>
+          <p:nvPr/>
+        </p:nvPicPr>
+        <p:blipFill>
+          <a:blip r:embed="rId5"/>
+          <a:srcRect l="9602" t="5170" r="33814" b="10008"/>
+          <a:stretch>
+            <a:fillRect/>
+          </a:stretch>
+        </p:blipFill>
+        <p:spPr>
+          <a:xfrm>
+            <a:off x="8286044" y="1000679"/>
+            <a:ext cx="2665482" cy="4497009"/>
+          </a:xfrm>
+          <a:prstGeom prst="rect">
+            <a:avLst/>
+          </a:prstGeom>
+        </p:spPr>
+      </p:pic>
+      <p:cxnSp>
+        <p:nvCxnSpPr>
+          <p:cNvPr id="4" name="Straight Arrow Connector 3">
+            <a:extLst>
+              <a:ext uri="{FF2B5EF4-FFF2-40B4-BE49-F238E27FC236}">
+                <a16:creationId xmlns:a16="http://schemas.microsoft.com/office/drawing/2014/main" id="{0A6ED816-010C-BF34-853B-BC3E02D2E44A}"/>
+              </a:ext>
+            </a:extLst>
+          </p:cNvPr>
+          <p:cNvCxnSpPr>
+            <a:cxnSpLocks/>
+          </p:cNvCxnSpPr>
+          <p:nvPr/>
+        </p:nvCxnSpPr>
+        <p:spPr>
+          <a:xfrm flipV="1">
+            <a:off x="9719733" y="1806222"/>
+            <a:ext cx="270934" cy="214489"/>
+          </a:xfrm>
+          <a:prstGeom prst="straightConnector1">
+            <a:avLst/>
+          </a:prstGeom>
+          <a:ln w="57150">
+            <a:solidFill>
+              <a:schemeClr val="tx1"/>
+            </a:solidFill>
+            <a:tailEnd type="triangle"/>
+          </a:ln>
+        </p:spPr>
+        <p:style>
+          <a:lnRef idx="2">
+            <a:schemeClr val="accent1"/>
+          </a:lnRef>
+          <a:fillRef idx="0">
+            <a:schemeClr val="accent1"/>
+          </a:fillRef>
+          <a:effectRef idx="1">
+            <a:schemeClr val="accent1"/>
+          </a:effectRef>
+          <a:fontRef idx="minor">
+            <a:schemeClr val="tx1"/>
+          </a:fontRef>
+        </p:style>
+      </p:cxnSp>
+    </p:spTree>
+    <p:extLst>
+      <p:ext uri="{BB962C8B-B14F-4D97-AF65-F5344CB8AC3E}">
+        <p14:creationId xmlns:p14="http://schemas.microsoft.com/office/powerpoint/2010/main" val="2001379730"/>
+      </p:ext>
+    </p:extLst>
+  </p:cSld>
+  <p:clrMapOvr>
+    <a:masterClrMapping/>
+  </p:clrMapOvr>
+</p:sld>
+</file>
+
+<file path=ppt/slides/slide4.xml><?xml version="1.0" encoding="utf-8"?>
+<p:sld xmlns:a="http://schemas.openxmlformats.org/drawingml/2006/main" xmlns:r="http://schemas.openxmlformats.org/officeDocument/2006/relationships" xmlns:p="http://schemas.openxmlformats.org/presentationml/2006/main">
+  <p:cSld>
+    <p:spTree>
+      <p:nvGrpSpPr>
+        <p:cNvPr id="1" name=""/>
+        <p:cNvGrpSpPr/>
+        <p:nvPr/>
+      </p:nvGrpSpPr>
+      <p:grpSpPr>
+        <a:xfrm>
+          <a:off x="0" y="0"/>
+          <a:ext cx="0" cy="0"/>
+          <a:chOff x="0" y="0"/>
+          <a:chExt cx="0" cy="0"/>
+        </a:xfrm>
+      </p:grpSpPr>
+      <p:pic>
+        <p:nvPicPr>
+          <p:cNvPr id="5" name="Picture 4">
+            <a:extLst>
+              <a:ext uri="{FF2B5EF4-FFF2-40B4-BE49-F238E27FC236}">
+                <a16:creationId xmlns:a16="http://schemas.microsoft.com/office/drawing/2014/main" id="{D3D27BC1-E113-85F2-872B-9F04BADD09D7}"/>
+              </a:ext>
+            </a:extLst>
+          </p:cNvPr>
+          <p:cNvPicPr>
+            <a:picLocks noChangeAspect="1"/>
+          </p:cNvPicPr>
+          <p:nvPr/>
+        </p:nvPicPr>
+        <p:blipFill>
+          <a:blip r:embed="rId2"/>
+          <a:stretch>
+            <a:fillRect/>
+          </a:stretch>
+        </p:blipFill>
+        <p:spPr>
+          <a:xfrm>
+            <a:off x="118334" y="256992"/>
+            <a:ext cx="7302419" cy="2176046"/>
+          </a:xfrm>
+          <a:prstGeom prst="rect">
+            <a:avLst/>
+          </a:prstGeom>
+        </p:spPr>
+      </p:pic>
+      <p:pic>
+        <p:nvPicPr>
+          <p:cNvPr id="7" name="Picture 6">
+            <a:extLst>
+              <a:ext uri="{FF2B5EF4-FFF2-40B4-BE49-F238E27FC236}">
+                <a16:creationId xmlns:a16="http://schemas.microsoft.com/office/drawing/2014/main" id="{AE4A85A0-00FA-FD3A-2FE5-F4151A7D4592}"/>
+              </a:ext>
+            </a:extLst>
+          </p:cNvPr>
+          <p:cNvPicPr>
+            <a:picLocks noChangeAspect="1"/>
+          </p:cNvPicPr>
+          <p:nvPr/>
+        </p:nvPicPr>
+        <p:blipFill>
+          <a:blip r:embed="rId3"/>
+          <a:stretch>
+            <a:fillRect/>
+          </a:stretch>
+        </p:blipFill>
+        <p:spPr>
+          <a:xfrm>
+            <a:off x="118333" y="2243513"/>
+            <a:ext cx="7302419" cy="2182628"/>
+          </a:xfrm>
+          <a:prstGeom prst="rect">
+            <a:avLst/>
+          </a:prstGeom>
+        </p:spPr>
+      </p:pic>
+      <p:pic>
+        <p:nvPicPr>
+          <p:cNvPr id="9" name="Picture 8">
+            <a:extLst>
+              <a:ext uri="{FF2B5EF4-FFF2-40B4-BE49-F238E27FC236}">
+                <a16:creationId xmlns:a16="http://schemas.microsoft.com/office/drawing/2014/main" id="{4F3C85A0-888F-A432-C0F6-740B0084C712}"/>
+              </a:ext>
+            </a:extLst>
+          </p:cNvPr>
+          <p:cNvPicPr>
+            <a:picLocks noChangeAspect="1"/>
+          </p:cNvPicPr>
+          <p:nvPr/>
+        </p:nvPicPr>
+        <p:blipFill>
+          <a:blip r:embed="rId4"/>
+          <a:stretch>
+            <a:fillRect/>
+          </a:stretch>
+        </p:blipFill>
+        <p:spPr>
+          <a:xfrm>
+            <a:off x="118333" y="4236043"/>
+            <a:ext cx="7324431" cy="2176046"/>
+          </a:xfrm>
+          <a:prstGeom prst="rect">
+            <a:avLst/>
+          </a:prstGeom>
+        </p:spPr>
+      </p:pic>
+      <p:pic>
+        <p:nvPicPr>
+          <p:cNvPr id="2" name="Picture 1">
+            <a:extLst>
+              <a:ext uri="{FF2B5EF4-FFF2-40B4-BE49-F238E27FC236}">
+                <a16:creationId xmlns:a16="http://schemas.microsoft.com/office/drawing/2014/main" id="{0C01A1EA-8279-AF51-67BE-87EA61607C4C}"/>
+              </a:ext>
+            </a:extLst>
+          </p:cNvPr>
+          <p:cNvPicPr>
+            <a:picLocks noChangeAspect="1"/>
+          </p:cNvPicPr>
+          <p:nvPr/>
+        </p:nvPicPr>
+        <p:blipFill>
+          <a:blip r:embed="rId5"/>
+          <a:srcRect l="9602" t="5170" r="33814" b="10008"/>
+          <a:stretch>
+            <a:fillRect/>
+          </a:stretch>
+        </p:blipFill>
+        <p:spPr>
+          <a:xfrm>
+            <a:off x="7586132" y="1180495"/>
+            <a:ext cx="2665482" cy="4497009"/>
+          </a:xfrm>
+          <a:prstGeom prst="rect">
+            <a:avLst/>
+          </a:prstGeom>
+        </p:spPr>
+      </p:pic>
+      <p:cxnSp>
+        <p:nvCxnSpPr>
+          <p:cNvPr id="3" name="Straight Arrow Connector 2">
+            <a:extLst>
+              <a:ext uri="{FF2B5EF4-FFF2-40B4-BE49-F238E27FC236}">
+                <a16:creationId xmlns:a16="http://schemas.microsoft.com/office/drawing/2014/main" id="{60181A69-C1D1-276A-1E26-6BCD813241D5}"/>
+              </a:ext>
+            </a:extLst>
+          </p:cNvPr>
+          <p:cNvCxnSpPr>
+            <a:cxnSpLocks/>
+          </p:cNvCxnSpPr>
+          <p:nvPr/>
+        </p:nvCxnSpPr>
+        <p:spPr>
+          <a:xfrm flipV="1">
+            <a:off x="9426221" y="2276573"/>
+            <a:ext cx="270934" cy="214489"/>
+          </a:xfrm>
+          <a:prstGeom prst="straightConnector1">
+            <a:avLst/>
+          </a:prstGeom>
+          <a:ln w="57150">
+            <a:solidFill>
+              <a:schemeClr val="tx1"/>
+            </a:solidFill>
+            <a:tailEnd type="triangle"/>
+          </a:ln>
+        </p:spPr>
+        <p:style>
+          <a:lnRef idx="2">
+            <a:schemeClr val="accent1"/>
+          </a:lnRef>
+          <a:fillRef idx="0">
+            <a:schemeClr val="accent1"/>
+          </a:fillRef>
+          <a:effectRef idx="1">
+            <a:schemeClr val="accent1"/>
+          </a:effectRef>
+          <a:fontRef idx="minor">
+            <a:schemeClr val="tx1"/>
+          </a:fontRef>
+        </p:style>
+      </p:cxnSp>
+    </p:spTree>
+    <p:extLst>
+      <p:ext uri="{BB962C8B-B14F-4D97-AF65-F5344CB8AC3E}">
+        <p14:creationId xmlns:p14="http://schemas.microsoft.com/office/powerpoint/2010/main" val="1223573483"/>
+      </p:ext>
+    </p:extLst>
+  </p:cSld>
+  <p:clrMapOvr>
+    <a:masterClrMapping/>
+  </p:clrMapOvr>
+</p:sld>
+</file>
+
+<file path=ppt/slides/slide5.xml><?xml version="1.0" encoding="utf-8"?>
+<p:sld xmlns:a="http://schemas.openxmlformats.org/drawingml/2006/main" xmlns:r="http://schemas.openxmlformats.org/officeDocument/2006/relationships" xmlns:p="http://schemas.openxmlformats.org/presentationml/2006/main">
+  <p:cSld>
+    <p:bg>
+      <p:bgPr>
+        <a:solidFill>
+          <a:schemeClr val="bg1"/>
+        </a:solidFill>
+        <a:effectLst/>
+      </p:bgPr>
+    </p:bg>
+    <p:spTree>
+      <p:nvGrpSpPr>
+        <p:cNvPr id="1" name=""/>
+        <p:cNvGrpSpPr/>
+        <p:nvPr/>
+      </p:nvGrpSpPr>
+      <p:grpSpPr>
+        <a:xfrm>
+          <a:off x="0" y="0"/>
+          <a:ext cx="0" cy="0"/>
+          <a:chOff x="0" y="0"/>
+          <a:chExt cx="0" cy="0"/>
+        </a:xfrm>
+      </p:grpSpPr>
+      <p:pic>
+        <p:nvPicPr>
+          <p:cNvPr id="7" name="Picture 6">
+            <a:extLst>
+              <a:ext uri="{FF2B5EF4-FFF2-40B4-BE49-F238E27FC236}">
+                <a16:creationId xmlns:a16="http://schemas.microsoft.com/office/drawing/2014/main" id="{9733A9F0-D7CB-32D5-BC50-E6004B053E7D}"/>
+              </a:ext>
+            </a:extLst>
+          </p:cNvPr>
+          <p:cNvPicPr>
+            <a:picLocks noChangeAspect="1"/>
+          </p:cNvPicPr>
+          <p:nvPr/>
+        </p:nvPicPr>
+        <p:blipFill>
+          <a:blip r:embed="rId2"/>
+          <a:stretch>
+            <a:fillRect/>
+          </a:stretch>
+        </p:blipFill>
+        <p:spPr>
+          <a:xfrm>
+            <a:off x="4051458" y="1654689"/>
+            <a:ext cx="3966481" cy="1926711"/>
+          </a:xfrm>
+          <a:prstGeom prst="rect">
+            <a:avLst/>
+          </a:prstGeom>
+        </p:spPr>
+      </p:pic>
+      <p:pic>
+        <p:nvPicPr>
+          <p:cNvPr id="9" name="Picture 8">
+            <a:extLst>
+              <a:ext uri="{FF2B5EF4-FFF2-40B4-BE49-F238E27FC236}">
+                <a16:creationId xmlns:a16="http://schemas.microsoft.com/office/drawing/2014/main" id="{F1B9636B-B134-A52B-0FBC-5F0E31E751F0}"/>
+              </a:ext>
+            </a:extLst>
+          </p:cNvPr>
+          <p:cNvPicPr>
+            <a:picLocks noChangeAspect="1"/>
+          </p:cNvPicPr>
+          <p:nvPr/>
+        </p:nvPicPr>
+        <p:blipFill>
+          <a:blip r:embed="rId3"/>
+          <a:stretch>
+            <a:fillRect/>
+          </a:stretch>
+        </p:blipFill>
+        <p:spPr>
+          <a:xfrm>
+            <a:off x="63273" y="1654689"/>
+            <a:ext cx="3966482" cy="1926711"/>
+          </a:xfrm>
+          <a:prstGeom prst="rect">
+            <a:avLst/>
+          </a:prstGeom>
+        </p:spPr>
+      </p:pic>
+      <p:pic>
+        <p:nvPicPr>
+          <p:cNvPr id="11" name="Picture 10">
+            <a:extLst>
+              <a:ext uri="{FF2B5EF4-FFF2-40B4-BE49-F238E27FC236}">
+                <a16:creationId xmlns:a16="http://schemas.microsoft.com/office/drawing/2014/main" id="{13D20122-D5A0-A536-3D62-A9B79541E3B1}"/>
+              </a:ext>
+            </a:extLst>
+          </p:cNvPr>
+          <p:cNvPicPr>
+            <a:picLocks noChangeAspect="1"/>
+          </p:cNvPicPr>
+          <p:nvPr/>
+        </p:nvPicPr>
+        <p:blipFill>
+          <a:blip r:embed="rId4"/>
+          <a:stretch>
+            <a:fillRect/>
+          </a:stretch>
+        </p:blipFill>
+        <p:spPr>
+          <a:xfrm>
+            <a:off x="8017939" y="1654689"/>
+            <a:ext cx="4067309" cy="1975688"/>
           </a:xfrm>
           <a:prstGeom prst="rect">
             <a:avLst/>
@@ -3596,7 +4536,367 @@
     </p:spTree>
     <p:extLst>
       <p:ext uri="{BB962C8B-B14F-4D97-AF65-F5344CB8AC3E}">
-        <p14:creationId xmlns:p14="http://schemas.microsoft.com/office/powerpoint/2010/main" val="3255813506"/>
+        <p14:creationId xmlns:p14="http://schemas.microsoft.com/office/powerpoint/2010/main" val="2514099804"/>
+      </p:ext>
+    </p:extLst>
+  </p:cSld>
+  <p:clrMapOvr>
+    <a:masterClrMapping/>
+  </p:clrMapOvr>
+</p:sld>
+</file>
+
+<file path=ppt/slides/slide6.xml><?xml version="1.0" encoding="utf-8"?>
+<p:sld xmlns:a="http://schemas.openxmlformats.org/drawingml/2006/main" xmlns:r="http://schemas.openxmlformats.org/officeDocument/2006/relationships" xmlns:p="http://schemas.openxmlformats.org/presentationml/2006/main">
+  <p:cSld>
+    <p:spTree>
+      <p:nvGrpSpPr>
+        <p:cNvPr id="1" name=""/>
+        <p:cNvGrpSpPr/>
+        <p:nvPr/>
+      </p:nvGrpSpPr>
+      <p:grpSpPr>
+        <a:xfrm>
+          <a:off x="0" y="0"/>
+          <a:ext cx="0" cy="0"/>
+          <a:chOff x="0" y="0"/>
+          <a:chExt cx="0" cy="0"/>
+        </a:xfrm>
+      </p:grpSpPr>
+      <p:pic>
+        <p:nvPicPr>
+          <p:cNvPr id="9" name="Picture 8">
+            <a:extLst>
+              <a:ext uri="{FF2B5EF4-FFF2-40B4-BE49-F238E27FC236}">
+                <a16:creationId xmlns:a16="http://schemas.microsoft.com/office/drawing/2014/main" id="{3CA582D4-9926-177E-5BC3-DBE689FC473D}"/>
+              </a:ext>
+            </a:extLst>
+          </p:cNvPr>
+          <p:cNvPicPr>
+            <a:picLocks noChangeAspect="1"/>
+          </p:cNvPicPr>
+          <p:nvPr/>
+        </p:nvPicPr>
+        <p:blipFill>
+          <a:blip r:embed="rId2"/>
+          <a:stretch>
+            <a:fillRect/>
+          </a:stretch>
+        </p:blipFill>
+        <p:spPr>
+          <a:xfrm>
+            <a:off x="231913" y="271295"/>
+            <a:ext cx="10462591" cy="2957253"/>
+          </a:xfrm>
+          <a:prstGeom prst="rect">
+            <a:avLst/>
+          </a:prstGeom>
+        </p:spPr>
+      </p:pic>
+      <p:pic>
+        <p:nvPicPr>
+          <p:cNvPr id="13" name="Picture 12">
+            <a:extLst>
+              <a:ext uri="{FF2B5EF4-FFF2-40B4-BE49-F238E27FC236}">
+                <a16:creationId xmlns:a16="http://schemas.microsoft.com/office/drawing/2014/main" id="{1C9121EF-95D0-7B80-3666-AF493031EED7}"/>
+              </a:ext>
+            </a:extLst>
+          </p:cNvPr>
+          <p:cNvPicPr>
+            <a:picLocks noChangeAspect="1"/>
+          </p:cNvPicPr>
+          <p:nvPr/>
+        </p:nvPicPr>
+        <p:blipFill>
+          <a:blip r:embed="rId3"/>
+          <a:stretch>
+            <a:fillRect/>
+          </a:stretch>
+        </p:blipFill>
+        <p:spPr>
+          <a:xfrm>
+            <a:off x="231913" y="3392791"/>
+            <a:ext cx="10495722" cy="2966618"/>
+          </a:xfrm>
+          <a:prstGeom prst="rect">
+            <a:avLst/>
+          </a:prstGeom>
+        </p:spPr>
+      </p:pic>
+    </p:spTree>
+    <p:extLst>
+      <p:ext uri="{BB962C8B-B14F-4D97-AF65-F5344CB8AC3E}">
+        <p14:creationId xmlns:p14="http://schemas.microsoft.com/office/powerpoint/2010/main" val="2392644134"/>
+      </p:ext>
+    </p:extLst>
+  </p:cSld>
+  <p:clrMapOvr>
+    <a:masterClrMapping/>
+  </p:clrMapOvr>
+</p:sld>
+</file>
+
+<file path=ppt/slides/slide7.xml><?xml version="1.0" encoding="utf-8"?>
+<p:sld xmlns:a="http://schemas.openxmlformats.org/drawingml/2006/main" xmlns:r="http://schemas.openxmlformats.org/officeDocument/2006/relationships" xmlns:p="http://schemas.openxmlformats.org/presentationml/2006/main">
+  <p:cSld>
+    <p:spTree>
+      <p:nvGrpSpPr>
+        <p:cNvPr id="1" name=""/>
+        <p:cNvGrpSpPr/>
+        <p:nvPr/>
+      </p:nvGrpSpPr>
+      <p:grpSpPr>
+        <a:xfrm>
+          <a:off x="0" y="0"/>
+          <a:ext cx="0" cy="0"/>
+          <a:chOff x="0" y="0"/>
+          <a:chExt cx="0" cy="0"/>
+        </a:xfrm>
+      </p:grpSpPr>
+      <p:pic>
+        <p:nvPicPr>
+          <p:cNvPr id="7" name="Picture 6">
+            <a:extLst>
+              <a:ext uri="{FF2B5EF4-FFF2-40B4-BE49-F238E27FC236}">
+                <a16:creationId xmlns:a16="http://schemas.microsoft.com/office/drawing/2014/main" id="{8EDBC232-EF73-5A85-2532-F6F51349897C}"/>
+              </a:ext>
+            </a:extLst>
+          </p:cNvPr>
+          <p:cNvPicPr>
+            <a:picLocks noChangeAspect="1"/>
+          </p:cNvPicPr>
+          <p:nvPr/>
+        </p:nvPicPr>
+        <p:blipFill>
+          <a:blip r:embed="rId2"/>
+          <a:stretch>
+            <a:fillRect/>
+          </a:stretch>
+        </p:blipFill>
+        <p:spPr>
+          <a:xfrm>
+            <a:off x="576469" y="3272095"/>
+            <a:ext cx="10495722" cy="2966618"/>
+          </a:xfrm>
+          <a:prstGeom prst="rect">
+            <a:avLst/>
+          </a:prstGeom>
+        </p:spPr>
+      </p:pic>
+      <p:pic>
+        <p:nvPicPr>
+          <p:cNvPr id="11" name="Picture 10">
+            <a:extLst>
+              <a:ext uri="{FF2B5EF4-FFF2-40B4-BE49-F238E27FC236}">
+                <a16:creationId xmlns:a16="http://schemas.microsoft.com/office/drawing/2014/main" id="{EFCF0AD2-E9CB-A00C-89F7-A8A083C6FA5D}"/>
+              </a:ext>
+            </a:extLst>
+          </p:cNvPr>
+          <p:cNvPicPr>
+            <a:picLocks noChangeAspect="1"/>
+          </p:cNvPicPr>
+          <p:nvPr/>
+        </p:nvPicPr>
+        <p:blipFill>
+          <a:blip r:embed="rId3"/>
+          <a:stretch>
+            <a:fillRect/>
+          </a:stretch>
+        </p:blipFill>
+        <p:spPr>
+          <a:xfrm>
+            <a:off x="576469" y="314843"/>
+            <a:ext cx="10462588" cy="2957252"/>
+          </a:xfrm>
+          <a:prstGeom prst="rect">
+            <a:avLst/>
+          </a:prstGeom>
+        </p:spPr>
+      </p:pic>
+    </p:spTree>
+    <p:extLst>
+      <p:ext uri="{BB962C8B-B14F-4D97-AF65-F5344CB8AC3E}">
+        <p14:creationId xmlns:p14="http://schemas.microsoft.com/office/powerpoint/2010/main" val="3821115340"/>
+      </p:ext>
+    </p:extLst>
+  </p:cSld>
+  <p:clrMapOvr>
+    <a:masterClrMapping/>
+  </p:clrMapOvr>
+</p:sld>
+</file>
+
+<file path=ppt/slides/slide8.xml><?xml version="1.0" encoding="utf-8"?>
+<p:sld xmlns:a="http://schemas.openxmlformats.org/drawingml/2006/main" xmlns:r="http://schemas.openxmlformats.org/officeDocument/2006/relationships" xmlns:p="http://schemas.openxmlformats.org/presentationml/2006/main">
+  <p:cSld>
+    <p:spTree>
+      <p:nvGrpSpPr>
+        <p:cNvPr id="1" name=""/>
+        <p:cNvGrpSpPr/>
+        <p:nvPr/>
+      </p:nvGrpSpPr>
+      <p:grpSpPr>
+        <a:xfrm>
+          <a:off x="0" y="0"/>
+          <a:ext cx="0" cy="0"/>
+          <a:chOff x="0" y="0"/>
+          <a:chExt cx="0" cy="0"/>
+        </a:xfrm>
+      </p:grpSpPr>
+      <p:pic>
+        <p:nvPicPr>
+          <p:cNvPr id="5" name="Picture 4">
+            <a:extLst>
+              <a:ext uri="{FF2B5EF4-FFF2-40B4-BE49-F238E27FC236}">
+                <a16:creationId xmlns:a16="http://schemas.microsoft.com/office/drawing/2014/main" id="{1BAA0150-2F5D-7372-B072-51DF25FD9A97}"/>
+              </a:ext>
+            </a:extLst>
+          </p:cNvPr>
+          <p:cNvPicPr>
+            <a:picLocks noChangeAspect="1"/>
+          </p:cNvPicPr>
+          <p:nvPr/>
+        </p:nvPicPr>
+        <p:blipFill>
+          <a:blip r:embed="rId2"/>
+          <a:stretch>
+            <a:fillRect/>
+          </a:stretch>
+        </p:blipFill>
+        <p:spPr>
+          <a:xfrm>
+            <a:off x="430306" y="479592"/>
+            <a:ext cx="11167486" cy="3156492"/>
+          </a:xfrm>
+          <a:prstGeom prst="rect">
+            <a:avLst/>
+          </a:prstGeom>
+        </p:spPr>
+      </p:pic>
+      <p:pic>
+        <p:nvPicPr>
+          <p:cNvPr id="7" name="Picture 6">
+            <a:extLst>
+              <a:ext uri="{FF2B5EF4-FFF2-40B4-BE49-F238E27FC236}">
+                <a16:creationId xmlns:a16="http://schemas.microsoft.com/office/drawing/2014/main" id="{4851D31A-135C-80B2-381D-E56F7FA589AF}"/>
+              </a:ext>
+            </a:extLst>
+          </p:cNvPr>
+          <p:cNvPicPr>
+            <a:picLocks noChangeAspect="1"/>
+          </p:cNvPicPr>
+          <p:nvPr/>
+        </p:nvPicPr>
+        <p:blipFill>
+          <a:blip r:embed="rId3"/>
+          <a:stretch>
+            <a:fillRect/>
+          </a:stretch>
+        </p:blipFill>
+        <p:spPr>
+          <a:xfrm>
+            <a:off x="657265" y="3636084"/>
+            <a:ext cx="10940527" cy="3096770"/>
+          </a:xfrm>
+          <a:prstGeom prst="rect">
+            <a:avLst/>
+          </a:prstGeom>
+        </p:spPr>
+      </p:pic>
+    </p:spTree>
+    <p:extLst>
+      <p:ext uri="{BB962C8B-B14F-4D97-AF65-F5344CB8AC3E}">
+        <p14:creationId xmlns:p14="http://schemas.microsoft.com/office/powerpoint/2010/main" val="430952040"/>
+      </p:ext>
+    </p:extLst>
+  </p:cSld>
+  <p:clrMapOvr>
+    <a:masterClrMapping/>
+  </p:clrMapOvr>
+</p:sld>
+</file>
+
+<file path=ppt/slides/slide9.xml><?xml version="1.0" encoding="utf-8"?>
+<p:sld xmlns:a="http://schemas.openxmlformats.org/drawingml/2006/main" xmlns:r="http://schemas.openxmlformats.org/officeDocument/2006/relationships" xmlns:p="http://schemas.openxmlformats.org/presentationml/2006/main">
+  <p:cSld>
+    <p:spTree>
+      <p:nvGrpSpPr>
+        <p:cNvPr id="1" name=""/>
+        <p:cNvGrpSpPr/>
+        <p:nvPr/>
+      </p:nvGrpSpPr>
+      <p:grpSpPr>
+        <a:xfrm>
+          <a:off x="0" y="0"/>
+          <a:ext cx="0" cy="0"/>
+          <a:chOff x="0" y="0"/>
+          <a:chExt cx="0" cy="0"/>
+        </a:xfrm>
+      </p:grpSpPr>
+      <p:pic>
+        <p:nvPicPr>
+          <p:cNvPr id="5" name="Picture 4">
+            <a:extLst>
+              <a:ext uri="{FF2B5EF4-FFF2-40B4-BE49-F238E27FC236}">
+                <a16:creationId xmlns:a16="http://schemas.microsoft.com/office/drawing/2014/main" id="{A860427E-F9C2-5AB5-130D-7D5ABB47581D}"/>
+              </a:ext>
+            </a:extLst>
+          </p:cNvPr>
+          <p:cNvPicPr>
+            <a:picLocks noChangeAspect="1"/>
+          </p:cNvPicPr>
+          <p:nvPr/>
+        </p:nvPicPr>
+        <p:blipFill>
+          <a:blip r:embed="rId2"/>
+          <a:stretch>
+            <a:fillRect/>
+          </a:stretch>
+        </p:blipFill>
+        <p:spPr>
+          <a:xfrm>
+            <a:off x="0" y="494751"/>
+            <a:ext cx="12192000" cy="2017259"/>
+          </a:xfrm>
+          <a:prstGeom prst="rect">
+            <a:avLst/>
+          </a:prstGeom>
+        </p:spPr>
+      </p:pic>
+      <p:pic>
+        <p:nvPicPr>
+          <p:cNvPr id="7" name="Picture 6">
+            <a:extLst>
+              <a:ext uri="{FF2B5EF4-FFF2-40B4-BE49-F238E27FC236}">
+                <a16:creationId xmlns:a16="http://schemas.microsoft.com/office/drawing/2014/main" id="{0D49B1DB-88EE-4769-CBBB-0F3A524DAE3F}"/>
+              </a:ext>
+            </a:extLst>
+          </p:cNvPr>
+          <p:cNvPicPr>
+            <a:picLocks noChangeAspect="1"/>
+          </p:cNvPicPr>
+          <p:nvPr/>
+        </p:nvPicPr>
+        <p:blipFill>
+          <a:blip r:embed="rId3"/>
+          <a:stretch>
+            <a:fillRect/>
+          </a:stretch>
+        </p:blipFill>
+        <p:spPr>
+          <a:xfrm>
+            <a:off x="0" y="2814703"/>
+            <a:ext cx="7035501" cy="2102849"/>
+          </a:xfrm>
+          <a:prstGeom prst="rect">
+            <a:avLst/>
+          </a:prstGeom>
+        </p:spPr>
+      </p:pic>
+    </p:spTree>
+    <p:extLst>
+      <p:ext uri="{BB962C8B-B14F-4D97-AF65-F5344CB8AC3E}">
+        <p14:creationId xmlns:p14="http://schemas.microsoft.com/office/powerpoint/2010/main" val="3740333013"/>
       </p:ext>
     </p:extLst>
   </p:cSld>

</xml_diff>